<commit_message>
Implement full-stack role-based authentication (Citizen & SDMA Authority) with JWT, demo logins, and protected routes
</commit_message>
<xml_diff>
--- a/NER_LEWS_Executive_Presentation.pptx
+++ b/NER_LEWS_Executive_Presentation.pptx
@@ -6,11 +6,6 @@
   </p:sldMasterIdLst>
   <p:sldIdLst>
     <p:sldId id="256" r:id="rId7"/>
-    <p:sldId id="257" r:id="rId8"/>
-    <p:sldId id="258" r:id="rId9"/>
-    <p:sldId id="259" r:id="rId10"/>
-    <p:sldId id="260" r:id="rId11"/>
-    <p:sldId id="261" r:id="rId12"/>
   </p:sldIdLst>
   <p:sldSz cx="12191695" cy="6858000" type="screen4x3"/>
   <p:notesSz cx="6858000" cy="9144000"/>
@@ -3093,2128 +3088,6 @@
         <p:nvPr/>
       </p:nvGrpSpPr>
       <p:grpSpPr/>
-      <p:sp>
-        <p:nvSpPr>
-          <p:cNvPr id="2" name="Rectangle 1"/>
-          <p:cNvSpPr/>
-          <p:nvPr/>
-        </p:nvSpPr>
-        <p:spPr>
-          <a:xfrm>
-            <a:off x="0" y="0"/>
-            <a:ext cx="12191695" cy="6858000"/>
-          </a:xfrm>
-          <a:prstGeom prst="rect">
-            <a:avLst/>
-          </a:prstGeom>
-          <a:solidFill>
-            <a:srgbClr val="091426"/>
-          </a:solidFill>
-          <a:ln>
-            <a:noFill/>
-          </a:ln>
-        </p:spPr>
-        <p:style>
-          <a:lnRef idx="1">
-            <a:schemeClr val="accent1"/>
-          </a:lnRef>
-          <a:fillRef idx="3">
-            <a:schemeClr val="accent1"/>
-          </a:fillRef>
-          <a:effectRef idx="2">
-            <a:schemeClr val="accent1"/>
-          </a:effectRef>
-          <a:fontRef idx="minor">
-            <a:schemeClr val="lt1"/>
-          </a:fontRef>
-        </p:style>
-        <p:txBody>
-          <a:bodyPr rtlCol="0" anchor="ctr"/>
-          <a:lstStyle/>
-          <a:p>
-            <a:pPr algn="ctr"/>
-          </a:p>
-        </p:txBody>
-      </p:sp>
-      <p:sp>
-        <p:nvSpPr>
-          <p:cNvPr id="3" name="Rounded Rectangle 2"/>
-          <p:cNvSpPr/>
-          <p:nvPr/>
-        </p:nvSpPr>
-        <p:spPr>
-          <a:xfrm>
-            <a:off x="731520" y="640080"/>
-            <a:ext cx="3840480" cy="502920"/>
-          </a:xfrm>
-          <a:prstGeom prst="roundRect">
-            <a:avLst/>
-          </a:prstGeom>
-          <a:solidFill>
-            <a:srgbClr val="EA580C"/>
-          </a:solidFill>
-          <a:ln>
-            <a:noFill/>
-          </a:ln>
-        </p:spPr>
-        <p:style>
-          <a:lnRef idx="1">
-            <a:schemeClr val="accent1"/>
-          </a:lnRef>
-          <a:fillRef idx="3">
-            <a:schemeClr val="accent1"/>
-          </a:fillRef>
-          <a:effectRef idx="2">
-            <a:schemeClr val="accent1"/>
-          </a:effectRef>
-          <a:fontRef idx="minor">
-            <a:schemeClr val="lt1"/>
-          </a:fontRef>
-        </p:style>
-        <p:txBody>
-          <a:bodyPr rtlCol="0" anchor="ctr"/>
-          <a:lstStyle/>
-          <a:p>
-            <a:pPr algn="ctr">
-              <a:defRPr sz="1300" b="1">
-                <a:solidFill>
-                  <a:srgbClr val="FFFFFF"/>
-                </a:solidFill>
-              </a:defRPr>
-            </a:pPr>
-            <a:r>
-              <a:t>DISASTER INTELLIGENCE PLATFORM</a:t>
-            </a:r>
-          </a:p>
-        </p:txBody>
-      </p:sp>
-      <p:sp>
-        <p:nvSpPr>
-          <p:cNvPr id="4" name="TextBox 3"/>
-          <p:cNvSpPr txBox="1"/>
-          <p:nvPr/>
-        </p:nvSpPr>
-        <p:spPr>
-          <a:xfrm>
-            <a:off x="731520" y="1280160"/>
-            <a:ext cx="6858000" cy="1645920"/>
-          </a:xfrm>
-          <a:prstGeom prst="rect">
-            <a:avLst/>
-          </a:prstGeom>
-          <a:noFill/>
-        </p:spPr>
-        <p:txBody>
-          <a:bodyPr wrap="square">
-            <a:spAutoFit/>
-          </a:bodyPr>
-          <a:lstStyle/>
-          <a:p>
-            <a:pPr>
-              <a:defRPr sz="4000" b="1">
-                <a:solidFill>
-                  <a:srgbClr val="FFFFFF"/>
-                </a:solidFill>
-              </a:defRPr>
-            </a:pPr>
-            <a:r>
-              <a:t>NER-LEWS</a:t>
-            </a:r>
-          </a:p>
-          <a:p>
-            <a:pPr>
-              <a:defRPr sz="2000" b="1">
-                <a:solidFill>
-                  <a:srgbClr val="D8E3FB"/>
-                </a:solidFill>
-              </a:defRPr>
-            </a:pPr>
-            <a:r>
-              <a:t>North Eastern Region Landslide Early Warning System</a:t>
-            </a:r>
-          </a:p>
-          <a:p>
-            <a:pPr>
-              <a:defRPr sz="1200">
-                <a:solidFill>
-                  <a:srgbClr val="BCC7DE"/>
-                </a:solidFill>
-              </a:defRPr>
-            </a:pPr>
-            <a:r>
-              <a:t>An AI &amp; Rule-Based Multi-Hazard Early Warning and Decision Support Platform for Northeast India</a:t>
-            </a:r>
-          </a:p>
-        </p:txBody>
-      </p:sp>
-      <p:sp>
-        <p:nvSpPr>
-          <p:cNvPr id="5" name="Rounded Rectangle 4"/>
-          <p:cNvSpPr/>
-          <p:nvPr/>
-        </p:nvSpPr>
-        <p:spPr>
-          <a:xfrm>
-            <a:off x="731520" y="3291840"/>
-            <a:ext cx="4389120" cy="2926080"/>
-          </a:xfrm>
-          <a:prstGeom prst="roundRect">
-            <a:avLst/>
-          </a:prstGeom>
-          <a:solidFill>
-            <a:srgbClr val="1E293B"/>
-          </a:solidFill>
-          <a:ln>
-            <a:solidFill>
-              <a:srgbClr val="475569"/>
-            </a:solidFill>
-          </a:ln>
-        </p:spPr>
-        <p:style>
-          <a:lnRef idx="1">
-            <a:schemeClr val="accent1"/>
-          </a:lnRef>
-          <a:fillRef idx="3">
-            <a:schemeClr val="accent1"/>
-          </a:fillRef>
-          <a:effectRef idx="2">
-            <a:schemeClr val="accent1"/>
-          </a:effectRef>
-          <a:fontRef idx="minor">
-            <a:schemeClr val="lt1"/>
-          </a:fontRef>
-        </p:style>
-        <p:txBody>
-          <a:bodyPr rtlCol="0" anchor="ctr" wrap="square" lIns="228600" tIns="228600"/>
-          <a:lstStyle/>
-          <a:p>
-            <a:pPr algn="ctr">
-              <a:defRPr sz="1200" b="1">
-                <a:solidFill>
-                  <a:srgbClr val="EA580C"/>
-                </a:solidFill>
-              </a:defRPr>
-            </a:pPr>
-            <a:r>
-              <a:t>PLATFORM OVERVIEW</a:t>
-            </a:r>
-          </a:p>
-          <a:p>
-            <a:pPr>
-              <a:defRPr sz="1000">
-                <a:solidFill>
-                  <a:srgbClr val="FFFFFF"/>
-                </a:solidFill>
-              </a:defRPr>
-            </a:pPr>
-            <a:r>
-              <a:t>• Domain: Landslide Hazard Early Warning &amp; Zonation</a:t>
-            </a:r>
-          </a:p>
-          <a:p>
-            <a:pPr>
-              <a:defRPr sz="1000">
-                <a:solidFill>
-                  <a:srgbClr val="FFFFFF"/>
-                </a:solidFill>
-              </a:defRPr>
-            </a:pPr>
-            <a:r>
-              <a:t>• Architecture: Web-GIS &amp; Rule-Based MCDA Engine</a:t>
-            </a:r>
-          </a:p>
-          <a:p>
-            <a:pPr>
-              <a:defRPr sz="1000">
-                <a:solidFill>
-                  <a:srgbClr val="FFFFFF"/>
-                </a:solidFill>
-              </a:defRPr>
-            </a:pPr>
-            <a:r>
-              <a:t>• Coverage: 8 North Eastern States (NER India)</a:t>
-            </a:r>
-          </a:p>
-          <a:p>
-            <a:pPr>
-              <a:defRPr sz="1000">
-                <a:solidFill>
-                  <a:srgbClr val="FFFFFF"/>
-                </a:solidFill>
-              </a:defRPr>
-            </a:pPr>
-            <a:r>
-              <a:t>• Key Corridors: NH-6, NH-54, NH-29, NH-10 Transit Lines</a:t>
-            </a:r>
-          </a:p>
-          <a:p>
-            <a:pPr>
-              <a:defRPr sz="1000">
-                <a:solidFill>
-                  <a:srgbClr val="FFFFFF"/>
-                </a:solidFill>
-              </a:defRPr>
-            </a:pPr>
-            <a:r>
-              <a:t>• Live App: https://ner-lews.vercel.app/</a:t>
-            </a:r>
-          </a:p>
-          <a:p>
-            <a:pPr>
-              <a:defRPr sz="1000">
-                <a:solidFill>
-                  <a:srgbClr val="FFFFFF"/>
-                </a:solidFill>
-              </a:defRPr>
-            </a:pPr>
-            <a:r>
-              <a:t>• REST API: https://ner-lews.onrender.com/</a:t>
-            </a:r>
-          </a:p>
-        </p:txBody>
-      </p:sp>
-      <p:pic>
-        <p:nvPicPr>
-          <p:cNvPr id="6" name="Picture 5" descr="07_ai_avatar_assistant.png"/>
-          <p:cNvPicPr>
-            <a:picLocks noChangeAspect="1"/>
-          </p:cNvPicPr>
-          <p:nvPr/>
-        </p:nvPicPr>
-        <p:blipFill>
-          <a:blip r:embed="rId2"/>
-          <a:stretch>
-            <a:fillRect/>
-          </a:stretch>
-        </p:blipFill>
-        <p:spPr>
-          <a:xfrm>
-            <a:off x="7772400" y="1280160"/>
-            <a:ext cx="3657600" cy="3657600"/>
-          </a:xfrm>
-          <a:prstGeom prst="rect">
-            <a:avLst/>
-          </a:prstGeom>
-        </p:spPr>
-      </p:pic>
-    </p:spTree>
-  </p:cSld>
-  <p:clrMapOvr>
-    <a:masterClrMapping/>
-  </p:clrMapOvr>
-</p:sld>
-</file>
-
-<file path=ppt/slides/slide2.xml><?xml version="1.0" encoding="utf-8"?>
-<p:sld xmlns:a="http://schemas.openxmlformats.org/drawingml/2006/main" xmlns:p="http://schemas.openxmlformats.org/presentationml/2006/main" xmlns:r="http://schemas.openxmlformats.org/officeDocument/2006/relationships">
-  <p:cSld>
-    <p:spTree>
-      <p:nvGrpSpPr>
-        <p:cNvPr id="1" name=""/>
-        <p:cNvGrpSpPr/>
-        <p:nvPr/>
-      </p:nvGrpSpPr>
-      <p:grpSpPr/>
-      <p:sp>
-        <p:nvSpPr>
-          <p:cNvPr id="2" name="Rectangle 1"/>
-          <p:cNvSpPr/>
-          <p:nvPr/>
-        </p:nvSpPr>
-        <p:spPr>
-          <a:xfrm>
-            <a:off x="0" y="0"/>
-            <a:ext cx="12191695" cy="1005840"/>
-          </a:xfrm>
-          <a:prstGeom prst="rect">
-            <a:avLst/>
-          </a:prstGeom>
-          <a:solidFill>
-            <a:srgbClr val="091426"/>
-          </a:solidFill>
-          <a:ln>
-            <a:noFill/>
-          </a:ln>
-        </p:spPr>
-        <p:style>
-          <a:lnRef idx="1">
-            <a:schemeClr val="accent1"/>
-          </a:lnRef>
-          <a:fillRef idx="3">
-            <a:schemeClr val="accent1"/>
-          </a:fillRef>
-          <a:effectRef idx="2">
-            <a:schemeClr val="accent1"/>
-          </a:effectRef>
-          <a:fontRef idx="minor">
-            <a:schemeClr val="lt1"/>
-          </a:fontRef>
-        </p:style>
-        <p:txBody>
-          <a:bodyPr rtlCol="0" anchor="ctr"/>
-          <a:lstStyle/>
-          <a:p>
-            <a:pPr algn="ctr"/>
-          </a:p>
-        </p:txBody>
-      </p:sp>
-      <p:sp>
-        <p:nvSpPr>
-          <p:cNvPr id="3" name="TextBox 2"/>
-          <p:cNvSpPr txBox="1"/>
-          <p:nvPr/>
-        </p:nvSpPr>
-        <p:spPr>
-          <a:xfrm>
-            <a:off x="731520" y="109728"/>
-            <a:ext cx="9601200" cy="777240"/>
-          </a:xfrm>
-          <a:prstGeom prst="rect">
-            <a:avLst/>
-          </a:prstGeom>
-          <a:noFill/>
-        </p:spPr>
-        <p:txBody>
-          <a:bodyPr wrap="square">
-            <a:spAutoFit/>
-          </a:bodyPr>
-          <a:lstStyle/>
-          <a:p>
-            <a:pPr>
-              <a:defRPr sz="2200" b="1">
-                <a:solidFill>
-                  <a:srgbClr val="FFFFFF"/>
-                </a:solidFill>
-                <a:latin typeface="Arial"/>
-              </a:defRPr>
-            </a:pPr>
-            <a:r>
-              <a:t>EXECUTIVE SUMMARY: THE NER-LEWS PLATFORM</a:t>
-            </a:r>
-          </a:p>
-          <a:p>
-            <a:pPr>
-              <a:defRPr sz="1100">
-                <a:solidFill>
-                  <a:srgbClr val="BCC7DE"/>
-                </a:solidFill>
-                <a:latin typeface="Arial"/>
-              </a:defRPr>
-            </a:pPr>
-            <a:r>
-              <a:t>Real-Time Slope Monitoring, Transparent Scoring &amp; Multilingual Alerts</a:t>
-            </a:r>
-          </a:p>
-        </p:txBody>
-      </p:sp>
-      <p:sp>
-        <p:nvSpPr>
-          <p:cNvPr id="4" name="Rounded Rectangle 3"/>
-          <p:cNvSpPr/>
-          <p:nvPr/>
-        </p:nvSpPr>
-        <p:spPr>
-          <a:xfrm>
-            <a:off x="11155680" y="228600"/>
-            <a:ext cx="548640" cy="548640"/>
-          </a:xfrm>
-          <a:prstGeom prst="roundRect">
-            <a:avLst/>
-          </a:prstGeom>
-          <a:solidFill>
-            <a:srgbClr val="EA580C"/>
-          </a:solidFill>
-          <a:ln>
-            <a:noFill/>
-          </a:ln>
-        </p:spPr>
-        <p:style>
-          <a:lnRef idx="1">
-            <a:schemeClr val="accent1"/>
-          </a:lnRef>
-          <a:fillRef idx="3">
-            <a:schemeClr val="accent1"/>
-          </a:fillRef>
-          <a:effectRef idx="2">
-            <a:schemeClr val="accent1"/>
-          </a:effectRef>
-          <a:fontRef idx="minor">
-            <a:schemeClr val="lt1"/>
-          </a:fontRef>
-        </p:style>
-        <p:txBody>
-          <a:bodyPr rtlCol="0" anchor="ctr"/>
-          <a:lstStyle/>
-          <a:p>
-            <a:pPr algn="ctr">
-              <a:defRPr sz="1600" b="1">
-                <a:solidFill>
-                  <a:srgbClr val="FFFFFF"/>
-                </a:solidFill>
-              </a:defRPr>
-            </a:pPr>
-            <a:r>
-              <a:t>2</a:t>
-            </a:r>
-          </a:p>
-        </p:txBody>
-      </p:sp>
-      <p:sp>
-        <p:nvSpPr>
-          <p:cNvPr id="5" name="TextBox 4"/>
-          <p:cNvSpPr txBox="1"/>
-          <p:nvPr/>
-        </p:nvSpPr>
-        <p:spPr>
-          <a:xfrm>
-            <a:off x="731520" y="6446520"/>
-            <a:ext cx="10698480" cy="320040"/>
-          </a:xfrm>
-          <a:prstGeom prst="rect">
-            <a:avLst/>
-          </a:prstGeom>
-          <a:noFill/>
-        </p:spPr>
-        <p:txBody>
-          <a:bodyPr wrap="none">
-            <a:spAutoFit/>
-          </a:bodyPr>
-          <a:lstStyle/>
-          <a:p>
-            <a:pPr>
-              <a:defRPr sz="1000">
-                <a:solidFill>
-                  <a:srgbClr val="64748B"/>
-                </a:solidFill>
-                <a:latin typeface="Arial"/>
-              </a:defRPr>
-            </a:pPr>
-            <a:r>
-              <a:t>NER-LEWS  |  Disaster Risk Reduction Platform  |  Live App: https://ner-lews.vercel.app/</a:t>
-            </a:r>
-          </a:p>
-        </p:txBody>
-      </p:sp>
-      <p:sp>
-        <p:nvSpPr>
-          <p:cNvPr id="6" name="Rounded Rectangle 5"/>
-          <p:cNvSpPr/>
-          <p:nvPr/>
-        </p:nvSpPr>
-        <p:spPr>
-          <a:xfrm>
-            <a:off x="731520" y="1280160"/>
-            <a:ext cx="5486400" cy="4937760"/>
-          </a:xfrm>
-          <a:prstGeom prst="roundRect">
-            <a:avLst/>
-          </a:prstGeom>
-          <a:solidFill>
-            <a:srgbClr val="FFFFFF"/>
-          </a:solidFill>
-          <a:ln>
-            <a:solidFill>
-              <a:srgbClr val="CBD5E1"/>
-            </a:solidFill>
-          </a:ln>
-        </p:spPr>
-        <p:style>
-          <a:lnRef idx="1">
-            <a:schemeClr val="accent1"/>
-          </a:lnRef>
-          <a:fillRef idx="3">
-            <a:schemeClr val="accent1"/>
-          </a:fillRef>
-          <a:effectRef idx="2">
-            <a:schemeClr val="accent1"/>
-          </a:effectRef>
-          <a:fontRef idx="minor">
-            <a:schemeClr val="lt1"/>
-          </a:fontRef>
-        </p:style>
-        <p:txBody>
-          <a:bodyPr rtlCol="0" anchor="ctr" wrap="square" lIns="228600" tIns="228600"/>
-          <a:lstStyle/>
-          <a:p>
-            <a:pPr algn="ctr">
-              <a:defRPr sz="1300" b="1">
-                <a:solidFill>
-                  <a:srgbClr val="BA1A1A"/>
-                </a:solidFill>
-              </a:defRPr>
-            </a:pPr>
-            <a:r>
-              <a:t>🚨 The Problem &amp; Solution Architecture</a:t>
-            </a:r>
-          </a:p>
-          <a:p>
-            <a:pPr>
-              <a:defRPr sz="1000">
-                <a:solidFill>
-                  <a:srgbClr val="091426"/>
-                </a:solidFill>
-              </a:defRPr>
-            </a:pPr>
-            <a:r>
-              <a:t>• Severe Monsoons: Heavy rainfall (&gt;2500mm/yr) causes slope destabilization across Eastern Himalayas.</a:t>
-            </a:r>
-          </a:p>
-          <a:p>
-            <a:pPr>
-              <a:defRPr sz="1000">
-                <a:solidFill>
-                  <a:srgbClr val="091426"/>
-                </a:solidFill>
-              </a:defRPr>
-            </a:pPr>
-            <a:r>
-              <a:t>• Highway Blockages: Essential transit lifelines (NH-6, NH-54) cut off entire state supplies for days.</a:t>
-            </a:r>
-          </a:p>
-          <a:p>
-            <a:pPr>
-              <a:defRPr sz="1000">
-                <a:solidFill>
-                  <a:srgbClr val="091426"/>
-                </a:solidFill>
-              </a:defRPr>
-            </a:pPr>
-            <a:r>
-              <a:t>• Transparent MCDA Scoring: Evaluates 5 physical parameters without unexplainable black-box ML.</a:t>
-            </a:r>
-          </a:p>
-          <a:p>
-            <a:pPr>
-              <a:defRPr sz="1000">
-                <a:solidFill>
-                  <a:srgbClr val="091426"/>
-                </a:solidFill>
-              </a:defRPr>
-            </a:pPr>
-            <a:r>
-              <a:t>• Interactive Web-GIS Map: Real-time telemetry monitoring for 10+ stations with radar hazard pins.</a:t>
-            </a:r>
-          </a:p>
-          <a:p>
-            <a:pPr>
-              <a:defRPr sz="1000">
-                <a:solidFill>
-                  <a:srgbClr val="091426"/>
-                </a:solidFill>
-              </a:defRPr>
-            </a:pPr>
-            <a:r>
-              <a:t>• Multilingual Voice Alerts: Native browser voice synthesis in English, Assamese, Hindi, and Bengali.</a:t>
-            </a:r>
-          </a:p>
-          <a:p>
-            <a:pPr>
-              <a:defRPr sz="1000">
-                <a:solidFill>
-                  <a:srgbClr val="091426"/>
-                </a:solidFill>
-              </a:defRPr>
-            </a:pPr>
-            <a:r>
-              <a:t>• Citizen Geotagged Reports: Crowdsourced GPS photo evidence with auto-sync to SDMA.</a:t>
-            </a:r>
-          </a:p>
-        </p:txBody>
-      </p:sp>
-      <p:pic>
-        <p:nvPicPr>
-          <p:cNvPr id="7" name="Picture 6" descr="02_gis_risk_map.png"/>
-          <p:cNvPicPr>
-            <a:picLocks noChangeAspect="1"/>
-          </p:cNvPicPr>
-          <p:nvPr/>
-        </p:nvPicPr>
-        <p:blipFill>
-          <a:blip r:embed="rId2"/>
-          <a:stretch>
-            <a:fillRect/>
-          </a:stretch>
-        </p:blipFill>
-        <p:spPr>
-          <a:xfrm>
-            <a:off x="6492240" y="1280160"/>
-            <a:ext cx="4937760" cy="3950208"/>
-          </a:xfrm>
-          <a:prstGeom prst="rect">
-            <a:avLst/>
-          </a:prstGeom>
-        </p:spPr>
-      </p:pic>
-    </p:spTree>
-  </p:cSld>
-  <p:clrMapOvr>
-    <a:masterClrMapping/>
-  </p:clrMapOvr>
-</p:sld>
-</file>
-
-<file path=ppt/slides/slide3.xml><?xml version="1.0" encoding="utf-8"?>
-<p:sld xmlns:a="http://schemas.openxmlformats.org/drawingml/2006/main" xmlns:p="http://schemas.openxmlformats.org/presentationml/2006/main" xmlns:r="http://schemas.openxmlformats.org/officeDocument/2006/relationships">
-  <p:cSld>
-    <p:spTree>
-      <p:nvGrpSpPr>
-        <p:cNvPr id="1" name=""/>
-        <p:cNvGrpSpPr/>
-        <p:nvPr/>
-      </p:nvGrpSpPr>
-      <p:grpSpPr/>
-      <p:sp>
-        <p:nvSpPr>
-          <p:cNvPr id="2" name="Rectangle 1"/>
-          <p:cNvSpPr/>
-          <p:nvPr/>
-        </p:nvSpPr>
-        <p:spPr>
-          <a:xfrm>
-            <a:off x="0" y="0"/>
-            <a:ext cx="12191695" cy="1005840"/>
-          </a:xfrm>
-          <a:prstGeom prst="rect">
-            <a:avLst/>
-          </a:prstGeom>
-          <a:solidFill>
-            <a:srgbClr val="091426"/>
-          </a:solidFill>
-          <a:ln>
-            <a:noFill/>
-          </a:ln>
-        </p:spPr>
-        <p:style>
-          <a:lnRef idx="1">
-            <a:schemeClr val="accent1"/>
-          </a:lnRef>
-          <a:fillRef idx="3">
-            <a:schemeClr val="accent1"/>
-          </a:fillRef>
-          <a:effectRef idx="2">
-            <a:schemeClr val="accent1"/>
-          </a:effectRef>
-          <a:fontRef idx="minor">
-            <a:schemeClr val="lt1"/>
-          </a:fontRef>
-        </p:style>
-        <p:txBody>
-          <a:bodyPr rtlCol="0" anchor="ctr"/>
-          <a:lstStyle/>
-          <a:p>
-            <a:pPr algn="ctr"/>
-          </a:p>
-        </p:txBody>
-      </p:sp>
-      <p:sp>
-        <p:nvSpPr>
-          <p:cNvPr id="3" name="TextBox 2"/>
-          <p:cNvSpPr txBox="1"/>
-          <p:nvPr/>
-        </p:nvSpPr>
-        <p:spPr>
-          <a:xfrm>
-            <a:off x="731520" y="109728"/>
-            <a:ext cx="9601200" cy="777240"/>
-          </a:xfrm>
-          <a:prstGeom prst="rect">
-            <a:avLst/>
-          </a:prstGeom>
-          <a:noFill/>
-        </p:spPr>
-        <p:txBody>
-          <a:bodyPr wrap="square">
-            <a:spAutoFit/>
-          </a:bodyPr>
-          <a:lstStyle/>
-          <a:p>
-            <a:pPr>
-              <a:defRPr sz="2200" b="1">
-                <a:solidFill>
-                  <a:srgbClr val="FFFFFF"/>
-                </a:solidFill>
-                <a:latin typeface="Arial"/>
-              </a:defRPr>
-            </a:pPr>
-            <a:r>
-              <a:t>TECHNICAL ARCHITECTURE &amp; RISK FORMULA</a:t>
-            </a:r>
-          </a:p>
-          <a:p>
-            <a:pPr>
-              <a:defRPr sz="1100">
-                <a:solidFill>
-                  <a:srgbClr val="BCC7DE"/>
-                </a:solidFill>
-                <a:latin typeface="Arial"/>
-              </a:defRPr>
-            </a:pPr>
-            <a:r>
-              <a:t>End-to-End Technology Stack, Multi-Criteria Algorithm &amp; Data Pipeline</a:t>
-            </a:r>
-          </a:p>
-        </p:txBody>
-      </p:sp>
-      <p:sp>
-        <p:nvSpPr>
-          <p:cNvPr id="4" name="Rounded Rectangle 3"/>
-          <p:cNvSpPr/>
-          <p:nvPr/>
-        </p:nvSpPr>
-        <p:spPr>
-          <a:xfrm>
-            <a:off x="11155680" y="228600"/>
-            <a:ext cx="548640" cy="548640"/>
-          </a:xfrm>
-          <a:prstGeom prst="roundRect">
-            <a:avLst/>
-          </a:prstGeom>
-          <a:solidFill>
-            <a:srgbClr val="EA580C"/>
-          </a:solidFill>
-          <a:ln>
-            <a:noFill/>
-          </a:ln>
-        </p:spPr>
-        <p:style>
-          <a:lnRef idx="1">
-            <a:schemeClr val="accent1"/>
-          </a:lnRef>
-          <a:fillRef idx="3">
-            <a:schemeClr val="accent1"/>
-          </a:fillRef>
-          <a:effectRef idx="2">
-            <a:schemeClr val="accent1"/>
-          </a:effectRef>
-          <a:fontRef idx="minor">
-            <a:schemeClr val="lt1"/>
-          </a:fontRef>
-        </p:style>
-        <p:txBody>
-          <a:bodyPr rtlCol="0" anchor="ctr"/>
-          <a:lstStyle/>
-          <a:p>
-            <a:pPr algn="ctr">
-              <a:defRPr sz="1600" b="1">
-                <a:solidFill>
-                  <a:srgbClr val="FFFFFF"/>
-                </a:solidFill>
-              </a:defRPr>
-            </a:pPr>
-            <a:r>
-              <a:t>3</a:t>
-            </a:r>
-          </a:p>
-        </p:txBody>
-      </p:sp>
-      <p:sp>
-        <p:nvSpPr>
-          <p:cNvPr id="5" name="TextBox 4"/>
-          <p:cNvSpPr txBox="1"/>
-          <p:nvPr/>
-        </p:nvSpPr>
-        <p:spPr>
-          <a:xfrm>
-            <a:off x="731520" y="6446520"/>
-            <a:ext cx="10698480" cy="320040"/>
-          </a:xfrm>
-          <a:prstGeom prst="rect">
-            <a:avLst/>
-          </a:prstGeom>
-          <a:noFill/>
-        </p:spPr>
-        <p:txBody>
-          <a:bodyPr wrap="none">
-            <a:spAutoFit/>
-          </a:bodyPr>
-          <a:lstStyle/>
-          <a:p>
-            <a:pPr>
-              <a:defRPr sz="1000">
-                <a:solidFill>
-                  <a:srgbClr val="64748B"/>
-                </a:solidFill>
-                <a:latin typeface="Arial"/>
-              </a:defRPr>
-            </a:pPr>
-            <a:r>
-              <a:t>NER-LEWS  |  Disaster Risk Reduction Platform  |  Live App: https://ner-lews.vercel.app/</a:t>
-            </a:r>
-          </a:p>
-        </p:txBody>
-      </p:sp>
-      <p:sp>
-        <p:nvSpPr>
-          <p:cNvPr id="6" name="Rounded Rectangle 5"/>
-          <p:cNvSpPr/>
-          <p:nvPr/>
-        </p:nvSpPr>
-        <p:spPr>
-          <a:xfrm>
-            <a:off x="731520" y="1280160"/>
-            <a:ext cx="5303520" cy="4937760"/>
-          </a:xfrm>
-          <a:prstGeom prst="roundRect">
-            <a:avLst/>
-          </a:prstGeom>
-          <a:solidFill>
-            <a:srgbClr val="FFFFFF"/>
-          </a:solidFill>
-          <a:ln>
-            <a:solidFill>
-              <a:srgbClr val="CBD5E1"/>
-            </a:solidFill>
-          </a:ln>
-        </p:spPr>
-        <p:style>
-          <a:lnRef idx="1">
-            <a:schemeClr val="accent1"/>
-          </a:lnRef>
-          <a:fillRef idx="3">
-            <a:schemeClr val="accent1"/>
-          </a:fillRef>
-          <a:effectRef idx="2">
-            <a:schemeClr val="accent1"/>
-          </a:effectRef>
-          <a:fontRef idx="minor">
-            <a:schemeClr val="lt1"/>
-          </a:fontRef>
-        </p:style>
-        <p:txBody>
-          <a:bodyPr rtlCol="0" anchor="ctr" wrap="square" lIns="228600" tIns="228600"/>
-          <a:lstStyle/>
-          <a:p>
-            <a:pPr algn="ctr">
-              <a:defRPr sz="1300" b="1">
-                <a:solidFill>
-                  <a:srgbClr val="EA580C"/>
-                </a:solidFill>
-              </a:defRPr>
-            </a:pPr>
-            <a:r>
-              <a:t>📐 Geotechnical Risk Scoring Formula</a:t>
-            </a:r>
-          </a:p>
-          <a:p>
-            <a:pPr>
-              <a:defRPr sz="950">
-                <a:solidFill>
-                  <a:srgbClr val="091426"/>
-                </a:solidFill>
-              </a:defRPr>
-            </a:pPr>
-            <a:r>
-              <a:t>Step 1: Normalization to 0-10 Sub-Scores:</a:t>
-            </a:r>
-          </a:p>
-          <a:p>
-            <a:pPr>
-              <a:defRPr sz="950">
-                <a:solidFill>
-                  <a:srgbClr val="091426"/>
-                </a:solidFill>
-              </a:defRPr>
-            </a:pPr>
-            <a:r>
-              <a:t>  • 24h Rain: 0mm→0 | 50mm→3 | 100mm→6 | 150mm+→10</a:t>
-            </a:r>
-          </a:p>
-          <a:p>
-            <a:pPr>
-              <a:defRPr sz="950">
-                <a:solidFill>
-                  <a:srgbClr val="091426"/>
-                </a:solidFill>
-              </a:defRPr>
-            </a:pPr>
-            <a:r>
-              <a:t>  • Soil Moisture: 0% to 100% linear (0-10)</a:t>
-            </a:r>
-          </a:p>
-          <a:p>
-            <a:pPr>
-              <a:defRPr sz="950">
-                <a:solidFill>
-                  <a:srgbClr val="091426"/>
-                </a:solidFill>
-              </a:defRPr>
-            </a:pPr>
-            <a:r>
-              <a:t>  • Elevation: 0-500m→2 | 500-1500m→5 | 1500-2500m→8 | 2500m+→10</a:t>
-            </a:r>
-          </a:p>
-          <a:p>
-            <a:pPr>
-              <a:defRPr sz="950">
-                <a:solidFill>
-                  <a:srgbClr val="091426"/>
-                </a:solidFill>
-              </a:defRPr>
-            </a:pPr>
-            <a:r>
-              <a:t>  • Humidity: 0% to 100% linear (0-10)</a:t>
-            </a:r>
-          </a:p>
-          <a:p>
-            <a:pPr>
-              <a:defRPr sz="950">
-                <a:solidFill>
-                  <a:srgbClr val="091426"/>
-                </a:solidFill>
-              </a:defRPr>
-            </a:pPr>
-            <a:r>
-              <a:t>  • Temperature Modifier: &lt;15°C or &gt;30°C adds +0.5 penalty</a:t>
-            </a:r>
-          </a:p>
-          <a:p>
-            <a:pPr>
-              <a:defRPr sz="950">
-                <a:solidFill>
-                  <a:srgbClr val="091426"/>
-                </a:solidFill>
-              </a:defRPr>
-            </a:pPr>
-          </a:p>
-          <a:p>
-            <a:pPr>
-              <a:defRPr sz="950">
-                <a:solidFill>
-                  <a:srgbClr val="091426"/>
-                </a:solidFill>
-              </a:defRPr>
-            </a:pPr>
-            <a:r>
-              <a:t>Step 2: Weighted Sum Calculation:</a:t>
-            </a:r>
-          </a:p>
-          <a:p>
-            <a:pPr>
-              <a:defRPr sz="950">
-                <a:solidFill>
-                  <a:srgbClr val="091426"/>
-                </a:solidFill>
-              </a:defRPr>
-            </a:pPr>
-            <a:r>
-              <a:t>  Final Score = (Precip × 0.35) + (Soil × 0.30) + (Elev × 0.20) + (Hum × 0.15) + TempMod</a:t>
-            </a:r>
-          </a:p>
-          <a:p>
-            <a:pPr>
-              <a:defRPr sz="950">
-                <a:solidFill>
-                  <a:srgbClr val="091426"/>
-                </a:solidFill>
-              </a:defRPr>
-            </a:pPr>
-          </a:p>
-          <a:p>
-            <a:pPr>
-              <a:defRPr sz="950">
-                <a:solidFill>
-                  <a:srgbClr val="091426"/>
-                </a:solidFill>
-              </a:defRPr>
-            </a:pPr>
-            <a:r>
-              <a:t>Step 3: 4 Severity Risk Bands:</a:t>
-            </a:r>
-          </a:p>
-          <a:p>
-            <a:pPr>
-              <a:defRPr sz="950">
-                <a:solidFill>
-                  <a:srgbClr val="091426"/>
-                </a:solidFill>
-              </a:defRPr>
-            </a:pPr>
-            <a:r>
-              <a:t>  • 0.0 – 3.0: LOW RISK (Green) -&gt; Routine monitoring</a:t>
-            </a:r>
-          </a:p>
-          <a:p>
-            <a:pPr>
-              <a:defRPr sz="950">
-                <a:solidFill>
-                  <a:srgbClr val="091426"/>
-                </a:solidFill>
-              </a:defRPr>
-            </a:pPr>
-            <a:r>
-              <a:t>  • 3.1 – 6.0: MODERATE RISK (Yellow) -&gt; Field officer inspection</a:t>
-            </a:r>
-          </a:p>
-          <a:p>
-            <a:pPr>
-              <a:defRPr sz="950">
-                <a:solidFill>
-                  <a:srgbClr val="091426"/>
-                </a:solidFill>
-              </a:defRPr>
-            </a:pPr>
-            <a:r>
-              <a:t>  • 6.1 – 8.0: HIGH RISK (Orange) -&gt; Road advisory &amp; alerts</a:t>
-            </a:r>
-          </a:p>
-          <a:p>
-            <a:pPr>
-              <a:defRPr sz="950">
-                <a:solidFill>
-                  <a:srgbClr val="091426"/>
-                </a:solidFill>
-              </a:defRPr>
-            </a:pPr>
-            <a:r>
-              <a:t>  • 8.1 – 10.0: SEVERE RISK (Red) -&gt; Immediate evacuation advisory</a:t>
-            </a:r>
-          </a:p>
-        </p:txBody>
-      </p:sp>
-      <p:pic>
-        <p:nvPicPr>
-          <p:cNvPr id="7" name="Picture 6" descr="03_risk_scoring_engine.png"/>
-          <p:cNvPicPr>
-            <a:picLocks noChangeAspect="1"/>
-          </p:cNvPicPr>
-          <p:nvPr/>
-        </p:nvPicPr>
-        <p:blipFill>
-          <a:blip r:embed="rId2"/>
-          <a:stretch>
-            <a:fillRect/>
-          </a:stretch>
-        </p:blipFill>
-        <p:spPr>
-          <a:xfrm>
-            <a:off x="6309360" y="1280160"/>
-            <a:ext cx="5120640" cy="4096512"/>
-          </a:xfrm>
-          <a:prstGeom prst="rect">
-            <a:avLst/>
-          </a:prstGeom>
-        </p:spPr>
-      </p:pic>
-    </p:spTree>
-  </p:cSld>
-  <p:clrMapOvr>
-    <a:masterClrMapping/>
-  </p:clrMapOvr>
-</p:sld>
-</file>
-
-<file path=ppt/slides/slide4.xml><?xml version="1.0" encoding="utf-8"?>
-<p:sld xmlns:a="http://schemas.openxmlformats.org/drawingml/2006/main" xmlns:p="http://schemas.openxmlformats.org/presentationml/2006/main" xmlns:r="http://schemas.openxmlformats.org/officeDocument/2006/relationships">
-  <p:cSld>
-    <p:spTree>
-      <p:nvGrpSpPr>
-        <p:cNvPr id="1" name=""/>
-        <p:cNvGrpSpPr/>
-        <p:nvPr/>
-      </p:nvGrpSpPr>
-      <p:grpSpPr/>
-      <p:sp>
-        <p:nvSpPr>
-          <p:cNvPr id="2" name="Rectangle 1"/>
-          <p:cNvSpPr/>
-          <p:nvPr/>
-        </p:nvSpPr>
-        <p:spPr>
-          <a:xfrm>
-            <a:off x="0" y="0"/>
-            <a:ext cx="12191695" cy="1005840"/>
-          </a:xfrm>
-          <a:prstGeom prst="rect">
-            <a:avLst/>
-          </a:prstGeom>
-          <a:solidFill>
-            <a:srgbClr val="091426"/>
-          </a:solidFill>
-          <a:ln>
-            <a:noFill/>
-          </a:ln>
-        </p:spPr>
-        <p:style>
-          <a:lnRef idx="1">
-            <a:schemeClr val="accent1"/>
-          </a:lnRef>
-          <a:fillRef idx="3">
-            <a:schemeClr val="accent1"/>
-          </a:fillRef>
-          <a:effectRef idx="2">
-            <a:schemeClr val="accent1"/>
-          </a:effectRef>
-          <a:fontRef idx="minor">
-            <a:schemeClr val="lt1"/>
-          </a:fontRef>
-        </p:style>
-        <p:txBody>
-          <a:bodyPr rtlCol="0" anchor="ctr"/>
-          <a:lstStyle/>
-          <a:p>
-            <a:pPr algn="ctr"/>
-          </a:p>
-        </p:txBody>
-      </p:sp>
-      <p:sp>
-        <p:nvSpPr>
-          <p:cNvPr id="3" name="TextBox 2"/>
-          <p:cNvSpPr txBox="1"/>
-          <p:nvPr/>
-        </p:nvSpPr>
-        <p:spPr>
-          <a:xfrm>
-            <a:off x="731520" y="109728"/>
-            <a:ext cx="9601200" cy="777240"/>
-          </a:xfrm>
-          <a:prstGeom prst="rect">
-            <a:avLst/>
-          </a:prstGeom>
-          <a:noFill/>
-        </p:spPr>
-        <p:txBody>
-          <a:bodyPr wrap="square">
-            <a:spAutoFit/>
-          </a:bodyPr>
-          <a:lstStyle/>
-          <a:p>
-            <a:pPr>
-              <a:defRPr sz="2200" b="1">
-                <a:solidFill>
-                  <a:srgbClr val="FFFFFF"/>
-                </a:solidFill>
-                <a:latin typeface="Arial"/>
-              </a:defRPr>
-            </a:pPr>
-            <a:r>
-              <a:t>FEASIBILITY, CHALLENGES &amp; MITIGATION</a:t>
-            </a:r>
-          </a:p>
-          <a:p>
-            <a:pPr>
-              <a:defRPr sz="1100">
-                <a:solidFill>
-                  <a:srgbClr val="BCC7DE"/>
-                </a:solidFill>
-                <a:latin typeface="Arial"/>
-              </a:defRPr>
-            </a:pPr>
-            <a:r>
-              <a:t>Operational Viability, Hill Terrain Obstacles and Engineering Solutions</a:t>
-            </a:r>
-          </a:p>
-        </p:txBody>
-      </p:sp>
-      <p:sp>
-        <p:nvSpPr>
-          <p:cNvPr id="4" name="Rounded Rectangle 3"/>
-          <p:cNvSpPr/>
-          <p:nvPr/>
-        </p:nvSpPr>
-        <p:spPr>
-          <a:xfrm>
-            <a:off x="11155680" y="228600"/>
-            <a:ext cx="548640" cy="548640"/>
-          </a:xfrm>
-          <a:prstGeom prst="roundRect">
-            <a:avLst/>
-          </a:prstGeom>
-          <a:solidFill>
-            <a:srgbClr val="EA580C"/>
-          </a:solidFill>
-          <a:ln>
-            <a:noFill/>
-          </a:ln>
-        </p:spPr>
-        <p:style>
-          <a:lnRef idx="1">
-            <a:schemeClr val="accent1"/>
-          </a:lnRef>
-          <a:fillRef idx="3">
-            <a:schemeClr val="accent1"/>
-          </a:fillRef>
-          <a:effectRef idx="2">
-            <a:schemeClr val="accent1"/>
-          </a:effectRef>
-          <a:fontRef idx="minor">
-            <a:schemeClr val="lt1"/>
-          </a:fontRef>
-        </p:style>
-        <p:txBody>
-          <a:bodyPr rtlCol="0" anchor="ctr"/>
-          <a:lstStyle/>
-          <a:p>
-            <a:pPr algn="ctr">
-              <a:defRPr sz="1600" b="1">
-                <a:solidFill>
-                  <a:srgbClr val="FFFFFF"/>
-                </a:solidFill>
-              </a:defRPr>
-            </a:pPr>
-            <a:r>
-              <a:t>4</a:t>
-            </a:r>
-          </a:p>
-        </p:txBody>
-      </p:sp>
-      <p:sp>
-        <p:nvSpPr>
-          <p:cNvPr id="5" name="TextBox 4"/>
-          <p:cNvSpPr txBox="1"/>
-          <p:nvPr/>
-        </p:nvSpPr>
-        <p:spPr>
-          <a:xfrm>
-            <a:off x="731520" y="6446520"/>
-            <a:ext cx="10698480" cy="320040"/>
-          </a:xfrm>
-          <a:prstGeom prst="rect">
-            <a:avLst/>
-          </a:prstGeom>
-          <a:noFill/>
-        </p:spPr>
-        <p:txBody>
-          <a:bodyPr wrap="none">
-            <a:spAutoFit/>
-          </a:bodyPr>
-          <a:lstStyle/>
-          <a:p>
-            <a:pPr>
-              <a:defRPr sz="1000">
-                <a:solidFill>
-                  <a:srgbClr val="64748B"/>
-                </a:solidFill>
-                <a:latin typeface="Arial"/>
-              </a:defRPr>
-            </a:pPr>
-            <a:r>
-              <a:t>NER-LEWS  |  Disaster Risk Reduction Platform  |  Live App: https://ner-lews.vercel.app/</a:t>
-            </a:r>
-          </a:p>
-        </p:txBody>
-      </p:sp>
-      <p:sp>
-        <p:nvSpPr>
-          <p:cNvPr id="6" name="Rounded Rectangle 5"/>
-          <p:cNvSpPr/>
-          <p:nvPr/>
-        </p:nvSpPr>
-        <p:spPr>
-          <a:xfrm>
-            <a:off x="731520" y="1280160"/>
-            <a:ext cx="5486400" cy="4937760"/>
-          </a:xfrm>
-          <a:prstGeom prst="roundRect">
-            <a:avLst/>
-          </a:prstGeom>
-          <a:solidFill>
-            <a:srgbClr val="FFFFFF"/>
-          </a:solidFill>
-          <a:ln>
-            <a:solidFill>
-              <a:srgbClr val="CBD5E1"/>
-            </a:solidFill>
-          </a:ln>
-        </p:spPr>
-        <p:style>
-          <a:lnRef idx="1">
-            <a:schemeClr val="accent1"/>
-          </a:lnRef>
-          <a:fillRef idx="3">
-            <a:schemeClr val="accent1"/>
-          </a:fillRef>
-          <a:effectRef idx="2">
-            <a:schemeClr val="accent1"/>
-          </a:effectRef>
-          <a:fontRef idx="minor">
-            <a:schemeClr val="lt1"/>
-          </a:fontRef>
-        </p:style>
-        <p:txBody>
-          <a:bodyPr rtlCol="0" anchor="ctr" wrap="square" lIns="228600" tIns="228600"/>
-          <a:lstStyle/>
-          <a:p>
-            <a:pPr algn="ctr">
-              <a:defRPr sz="1300" b="1">
-                <a:solidFill>
-                  <a:srgbClr val="22C55E"/>
-                </a:solidFill>
-              </a:defRPr>
-            </a:pPr>
-            <a:r>
-              <a:t>📊 Feasibility Analysis &amp; Practical Solutions</a:t>
-            </a:r>
-          </a:p>
-          <a:p>
-            <a:pPr>
-              <a:defRPr sz="1000">
-                <a:solidFill>
-                  <a:srgbClr val="091426"/>
-                </a:solidFill>
-              </a:defRPr>
-            </a:pPr>
-            <a:r>
-              <a:t>• Technical Viability: 100% built and live in production; sub-second page loads on 3G/4G.</a:t>
-            </a:r>
-          </a:p>
-          <a:p>
-            <a:pPr>
-              <a:defRPr sz="1000">
-                <a:solidFill>
-                  <a:srgbClr val="091426"/>
-                </a:solidFill>
-              </a:defRPr>
-            </a:pPr>
-            <a:r>
-              <a:t>• Financial Feasibility: Eliminates proprietary GIS and TTS licensing fees; zero operational server cost on free tier.</a:t>
-            </a:r>
-          </a:p>
-          <a:p>
-            <a:pPr>
-              <a:defRPr sz="1000">
-                <a:solidFill>
-                  <a:srgbClr val="091426"/>
-                </a:solidFill>
-              </a:defRPr>
-            </a:pPr>
-            <a:r>
-              <a:t>• Hill Connectivity: Client-side offline evaluation engine and seed caching keep alerts functional without network.</a:t>
-            </a:r>
-          </a:p>
-          <a:p>
-            <a:pPr>
-              <a:defRPr sz="1000">
-                <a:solidFill>
-                  <a:srgbClr val="091426"/>
-                </a:solidFill>
-              </a:defRPr>
-            </a:pPr>
-            <a:r>
-              <a:t>• Regional Languages: Native browser voice synthesis in Assamese, Bengali, and Hindi with regional dialect mappings.</a:t>
-            </a:r>
-          </a:p>
-          <a:p>
-            <a:pPr>
-              <a:defRPr sz="1000">
-                <a:solidFill>
-                  <a:srgbClr val="091426"/>
-                </a:solidFill>
-              </a:defRPr>
-            </a:pPr>
-            <a:r>
-              <a:t>• Hardware Gaps: Citizen hazard crowdsourcing with geotagged photo proof bridges sparse sensor networks.</a:t>
-            </a:r>
-          </a:p>
-        </p:txBody>
-      </p:sp>
-      <p:pic>
-        <p:nvPicPr>
-          <p:cNvPr id="7" name="Picture 6" descr="05_citizen_field_report.png"/>
-          <p:cNvPicPr>
-            <a:picLocks noChangeAspect="1"/>
-          </p:cNvPicPr>
-          <p:nvPr/>
-        </p:nvPicPr>
-        <p:blipFill>
-          <a:blip r:embed="rId2"/>
-          <a:stretch>
-            <a:fillRect/>
-          </a:stretch>
-        </p:blipFill>
-        <p:spPr>
-          <a:xfrm>
-            <a:off x="6492240" y="1280160"/>
-            <a:ext cx="4937760" cy="9584319"/>
-          </a:xfrm>
-          <a:prstGeom prst="rect">
-            <a:avLst/>
-          </a:prstGeom>
-        </p:spPr>
-      </p:pic>
-    </p:spTree>
-  </p:cSld>
-  <p:clrMapOvr>
-    <a:masterClrMapping/>
-  </p:clrMapOvr>
-</p:sld>
-</file>
-
-<file path=ppt/slides/slide5.xml><?xml version="1.0" encoding="utf-8"?>
-<p:sld xmlns:a="http://schemas.openxmlformats.org/drawingml/2006/main" xmlns:p="http://schemas.openxmlformats.org/presentationml/2006/main" xmlns:r="http://schemas.openxmlformats.org/officeDocument/2006/relationships">
-  <p:cSld>
-    <p:spTree>
-      <p:nvGrpSpPr>
-        <p:cNvPr id="1" name=""/>
-        <p:cNvGrpSpPr/>
-        <p:nvPr/>
-      </p:nvGrpSpPr>
-      <p:grpSpPr/>
-      <p:sp>
-        <p:nvSpPr>
-          <p:cNvPr id="2" name="Rectangle 1"/>
-          <p:cNvSpPr/>
-          <p:nvPr/>
-        </p:nvSpPr>
-        <p:spPr>
-          <a:xfrm>
-            <a:off x="0" y="0"/>
-            <a:ext cx="12191695" cy="1005840"/>
-          </a:xfrm>
-          <a:prstGeom prst="rect">
-            <a:avLst/>
-          </a:prstGeom>
-          <a:solidFill>
-            <a:srgbClr val="091426"/>
-          </a:solidFill>
-          <a:ln>
-            <a:noFill/>
-          </a:ln>
-        </p:spPr>
-        <p:style>
-          <a:lnRef idx="1">
-            <a:schemeClr val="accent1"/>
-          </a:lnRef>
-          <a:fillRef idx="3">
-            <a:schemeClr val="accent1"/>
-          </a:fillRef>
-          <a:effectRef idx="2">
-            <a:schemeClr val="accent1"/>
-          </a:effectRef>
-          <a:fontRef idx="minor">
-            <a:schemeClr val="lt1"/>
-          </a:fontRef>
-        </p:style>
-        <p:txBody>
-          <a:bodyPr rtlCol="0" anchor="ctr"/>
-          <a:lstStyle/>
-          <a:p>
-            <a:pPr algn="ctr"/>
-          </a:p>
-        </p:txBody>
-      </p:sp>
-      <p:sp>
-        <p:nvSpPr>
-          <p:cNvPr id="3" name="TextBox 2"/>
-          <p:cNvSpPr txBox="1"/>
-          <p:nvPr/>
-        </p:nvSpPr>
-        <p:spPr>
-          <a:xfrm>
-            <a:off x="731520" y="109728"/>
-            <a:ext cx="9601200" cy="777240"/>
-          </a:xfrm>
-          <a:prstGeom prst="rect">
-            <a:avLst/>
-          </a:prstGeom>
-          <a:noFill/>
-        </p:spPr>
-        <p:txBody>
-          <a:bodyPr wrap="square">
-            <a:spAutoFit/>
-          </a:bodyPr>
-          <a:lstStyle/>
-          <a:p>
-            <a:pPr>
-              <a:defRPr sz="2200" b="1">
-                <a:solidFill>
-                  <a:srgbClr val="FFFFFF"/>
-                </a:solidFill>
-                <a:latin typeface="Arial"/>
-              </a:defRPr>
-            </a:pPr>
-            <a:r>
-              <a:t>IMPACT, BENEFICIARIES &amp; AUDIO ADVISORIES</a:t>
-            </a:r>
-          </a:p>
-          <a:p>
-            <a:pPr>
-              <a:defRPr sz="1100">
-                <a:solidFill>
-                  <a:srgbClr val="BCC7DE"/>
-                </a:solidFill>
-                <a:latin typeface="Arial"/>
-              </a:defRPr>
-            </a:pPr>
-            <a:r>
-              <a:t>Social, Economic, and Disaster Risk Reduction (DRR) Benefits for Northeast India</a:t>
-            </a:r>
-          </a:p>
-        </p:txBody>
-      </p:sp>
-      <p:sp>
-        <p:nvSpPr>
-          <p:cNvPr id="4" name="Rounded Rectangle 3"/>
-          <p:cNvSpPr/>
-          <p:nvPr/>
-        </p:nvSpPr>
-        <p:spPr>
-          <a:xfrm>
-            <a:off x="11155680" y="228600"/>
-            <a:ext cx="548640" cy="548640"/>
-          </a:xfrm>
-          <a:prstGeom prst="roundRect">
-            <a:avLst/>
-          </a:prstGeom>
-          <a:solidFill>
-            <a:srgbClr val="EA580C"/>
-          </a:solidFill>
-          <a:ln>
-            <a:noFill/>
-          </a:ln>
-        </p:spPr>
-        <p:style>
-          <a:lnRef idx="1">
-            <a:schemeClr val="accent1"/>
-          </a:lnRef>
-          <a:fillRef idx="3">
-            <a:schemeClr val="accent1"/>
-          </a:fillRef>
-          <a:effectRef idx="2">
-            <a:schemeClr val="accent1"/>
-          </a:effectRef>
-          <a:fontRef idx="minor">
-            <a:schemeClr val="lt1"/>
-          </a:fontRef>
-        </p:style>
-        <p:txBody>
-          <a:bodyPr rtlCol="0" anchor="ctr"/>
-          <a:lstStyle/>
-          <a:p>
-            <a:pPr algn="ctr">
-              <a:defRPr sz="1600" b="1">
-                <a:solidFill>
-                  <a:srgbClr val="FFFFFF"/>
-                </a:solidFill>
-              </a:defRPr>
-            </a:pPr>
-            <a:r>
-              <a:t>5</a:t>
-            </a:r>
-          </a:p>
-        </p:txBody>
-      </p:sp>
-      <p:sp>
-        <p:nvSpPr>
-          <p:cNvPr id="5" name="TextBox 4"/>
-          <p:cNvSpPr txBox="1"/>
-          <p:nvPr/>
-        </p:nvSpPr>
-        <p:spPr>
-          <a:xfrm>
-            <a:off x="731520" y="6446520"/>
-            <a:ext cx="10698480" cy="320040"/>
-          </a:xfrm>
-          <a:prstGeom prst="rect">
-            <a:avLst/>
-          </a:prstGeom>
-          <a:noFill/>
-        </p:spPr>
-        <p:txBody>
-          <a:bodyPr wrap="none">
-            <a:spAutoFit/>
-          </a:bodyPr>
-          <a:lstStyle/>
-          <a:p>
-            <a:pPr>
-              <a:defRPr sz="1000">
-                <a:solidFill>
-                  <a:srgbClr val="64748B"/>
-                </a:solidFill>
-                <a:latin typeface="Arial"/>
-              </a:defRPr>
-            </a:pPr>
-            <a:r>
-              <a:t>NER-LEWS  |  Disaster Risk Reduction Platform  |  Live App: https://ner-lews.vercel.app/</a:t>
-            </a:r>
-          </a:p>
-        </p:txBody>
-      </p:sp>
-      <p:sp>
-        <p:nvSpPr>
-          <p:cNvPr id="6" name="Rounded Rectangle 5"/>
-          <p:cNvSpPr/>
-          <p:nvPr/>
-        </p:nvSpPr>
-        <p:spPr>
-          <a:xfrm>
-            <a:off x="731520" y="1280160"/>
-            <a:ext cx="5486400" cy="4937760"/>
-          </a:xfrm>
-          <a:prstGeom prst="roundRect">
-            <a:avLst/>
-          </a:prstGeom>
-          <a:solidFill>
-            <a:srgbClr val="FFFFFF"/>
-          </a:solidFill>
-          <a:ln>
-            <a:solidFill>
-              <a:srgbClr val="CBD5E1"/>
-            </a:solidFill>
-          </a:ln>
-        </p:spPr>
-        <p:style>
-          <a:lnRef idx="1">
-            <a:schemeClr val="accent1"/>
-          </a:lnRef>
-          <a:fillRef idx="3">
-            <a:schemeClr val="accent1"/>
-          </a:fillRef>
-          <a:effectRef idx="2">
-            <a:schemeClr val="accent1"/>
-          </a:effectRef>
-          <a:fontRef idx="minor">
-            <a:schemeClr val="lt1"/>
-          </a:fontRef>
-        </p:style>
-        <p:txBody>
-          <a:bodyPr rtlCol="0" anchor="ctr" wrap="square" lIns="228600" tIns="228600"/>
-          <a:lstStyle/>
-          <a:p>
-            <a:pPr algn="ctr">
-              <a:defRPr sz="1300" b="1">
-                <a:solidFill>
-                  <a:srgbClr val="BA1A1A"/>
-                </a:solidFill>
-              </a:defRPr>
-            </a:pPr>
-            <a:r>
-              <a:t>👥 Public Safety &amp; Economic Preservation</a:t>
-            </a:r>
-          </a:p>
-          <a:p>
-            <a:pPr>
-              <a:defRPr sz="1000">
-                <a:solidFill>
-                  <a:srgbClr val="091426"/>
-                </a:solidFill>
-              </a:defRPr>
-            </a:pPr>
-            <a:r>
-              <a:t>• Early Evacuation Time: 6 to 24 hour prescriptive warning window before slope saturation triggers rupture.</a:t>
-            </a:r>
-          </a:p>
-          <a:p>
-            <a:pPr>
-              <a:defRPr sz="1000">
-                <a:solidFill>
-                  <a:srgbClr val="091426"/>
-                </a:solidFill>
-              </a:defRPr>
-            </a:pPr>
-            <a:r>
-              <a:t>• Universal Accessibility: Multilingual voice advisories ensure illiterate, elderly, and rural citizens receive alerts.</a:t>
-            </a:r>
-          </a:p>
-          <a:p>
-            <a:pPr>
-              <a:defRPr sz="1000">
-                <a:solidFill>
-                  <a:srgbClr val="091426"/>
-                </a:solidFill>
-              </a:defRPr>
-            </a:pPr>
-            <a:r>
-              <a:t>• Highway Transit Preservation: Prevents multi-day supply chain blockages along NH-6, NH-54, and NH-29.</a:t>
-            </a:r>
-          </a:p>
-          <a:p>
-            <a:pPr>
-              <a:defRPr sz="1000">
-                <a:solidFill>
-                  <a:srgbClr val="091426"/>
-                </a:solidFill>
-              </a:defRPr>
-            </a:pPr>
-            <a:r>
-              <a:t>• Targeted Resource Dispatch: Empowers SDRF &amp; District Magistrates with pinpointed hazard sector intelligence.</a:t>
-            </a:r>
-          </a:p>
-          <a:p>
-            <a:pPr>
-              <a:defRPr sz="1000">
-                <a:solidFill>
-                  <a:srgbClr val="091426"/>
-                </a:solidFill>
-              </a:defRPr>
-            </a:pPr>
-            <a:r>
-              <a:t>• Aligned with Sendai Framework: Directly supports global DRR Target G (Multi-hazard early warning systems).</a:t>
-            </a:r>
-          </a:p>
-        </p:txBody>
-      </p:sp>
-      <p:pic>
-        <p:nvPicPr>
-          <p:cNvPr id="7" name="Picture 6" descr="04_multilingual_alerts.png"/>
-          <p:cNvPicPr>
-            <a:picLocks noChangeAspect="1"/>
-          </p:cNvPicPr>
-          <p:nvPr/>
-        </p:nvPicPr>
-        <p:blipFill>
-          <a:blip r:embed="rId2"/>
-          <a:stretch>
-            <a:fillRect/>
-          </a:stretch>
-        </p:blipFill>
-        <p:spPr>
-          <a:xfrm>
-            <a:off x="6492240" y="1280160"/>
-            <a:ext cx="4937760" cy="14576413"/>
-          </a:xfrm>
-          <a:prstGeom prst="rect">
-            <a:avLst/>
-          </a:prstGeom>
-        </p:spPr>
-      </p:pic>
-    </p:spTree>
-  </p:cSld>
-  <p:clrMapOvr>
-    <a:masterClrMapping/>
-  </p:clrMapOvr>
-</p:sld>
-</file>
-
-<file path=ppt/slides/slide6.xml><?xml version="1.0" encoding="utf-8"?>
-<p:sld xmlns:a="http://schemas.openxmlformats.org/drawingml/2006/main" xmlns:p="http://schemas.openxmlformats.org/presentationml/2006/main" xmlns:r="http://schemas.openxmlformats.org/officeDocument/2006/relationships">
-  <p:cSld>
-    <p:spTree>
-      <p:nvGrpSpPr>
-        <p:cNvPr id="1" name=""/>
-        <p:cNvGrpSpPr/>
-        <p:nvPr/>
-      </p:nvGrpSpPr>
-      <p:grpSpPr/>
-      <p:sp>
-        <p:nvSpPr>
-          <p:cNvPr id="2" name="Rectangle 1"/>
-          <p:cNvSpPr/>
-          <p:nvPr/>
-        </p:nvSpPr>
-        <p:spPr>
-          <a:xfrm>
-            <a:off x="0" y="0"/>
-            <a:ext cx="12191695" cy="1005840"/>
-          </a:xfrm>
-          <a:prstGeom prst="rect">
-            <a:avLst/>
-          </a:prstGeom>
-          <a:solidFill>
-            <a:srgbClr val="091426"/>
-          </a:solidFill>
-          <a:ln>
-            <a:noFill/>
-          </a:ln>
-        </p:spPr>
-        <p:style>
-          <a:lnRef idx="1">
-            <a:schemeClr val="accent1"/>
-          </a:lnRef>
-          <a:fillRef idx="3">
-            <a:schemeClr val="accent1"/>
-          </a:fillRef>
-          <a:effectRef idx="2">
-            <a:schemeClr val="accent1"/>
-          </a:effectRef>
-          <a:fontRef idx="minor">
-            <a:schemeClr val="lt1"/>
-          </a:fontRef>
-        </p:style>
-        <p:txBody>
-          <a:bodyPr rtlCol="0" anchor="ctr"/>
-          <a:lstStyle/>
-          <a:p>
-            <a:pPr algn="ctr"/>
-          </a:p>
-        </p:txBody>
-      </p:sp>
-      <p:sp>
-        <p:nvSpPr>
-          <p:cNvPr id="3" name="TextBox 2"/>
-          <p:cNvSpPr txBox="1"/>
-          <p:nvPr/>
-        </p:nvSpPr>
-        <p:spPr>
-          <a:xfrm>
-            <a:off x="731520" y="109728"/>
-            <a:ext cx="9601200" cy="777240"/>
-          </a:xfrm>
-          <a:prstGeom prst="rect">
-            <a:avLst/>
-          </a:prstGeom>
-          <a:noFill/>
-        </p:spPr>
-        <p:txBody>
-          <a:bodyPr wrap="square">
-            <a:spAutoFit/>
-          </a:bodyPr>
-          <a:lstStyle/>
-          <a:p>
-            <a:pPr>
-              <a:defRPr sz="2200" b="1">
-                <a:solidFill>
-                  <a:srgbClr val="FFFFFF"/>
-                </a:solidFill>
-                <a:latin typeface="Arial"/>
-              </a:defRPr>
-            </a:pPr>
-            <a:r>
-              <a:t>RESEARCH GROUNDING &amp; AUTHORITY DASHBOARD</a:t>
-            </a:r>
-          </a:p>
-          <a:p>
-            <a:pPr>
-              <a:defRPr sz="1100">
-                <a:solidFill>
-                  <a:srgbClr val="BCC7DE"/>
-                </a:solidFill>
-                <a:latin typeface="Arial"/>
-              </a:defRPr>
-            </a:pPr>
-            <a:r>
-              <a:t>Geotechnical Basis, Authority Portal &amp; Live Production Deliverables</a:t>
-            </a:r>
-          </a:p>
-        </p:txBody>
-      </p:sp>
-      <p:sp>
-        <p:nvSpPr>
-          <p:cNvPr id="4" name="Rounded Rectangle 3"/>
-          <p:cNvSpPr/>
-          <p:nvPr/>
-        </p:nvSpPr>
-        <p:spPr>
-          <a:xfrm>
-            <a:off x="11155680" y="228600"/>
-            <a:ext cx="548640" cy="548640"/>
-          </a:xfrm>
-          <a:prstGeom prst="roundRect">
-            <a:avLst/>
-          </a:prstGeom>
-          <a:solidFill>
-            <a:srgbClr val="EA580C"/>
-          </a:solidFill>
-          <a:ln>
-            <a:noFill/>
-          </a:ln>
-        </p:spPr>
-        <p:style>
-          <a:lnRef idx="1">
-            <a:schemeClr val="accent1"/>
-          </a:lnRef>
-          <a:fillRef idx="3">
-            <a:schemeClr val="accent1"/>
-          </a:fillRef>
-          <a:effectRef idx="2">
-            <a:schemeClr val="accent1"/>
-          </a:effectRef>
-          <a:fontRef idx="minor">
-            <a:schemeClr val="lt1"/>
-          </a:fontRef>
-        </p:style>
-        <p:txBody>
-          <a:bodyPr rtlCol="0" anchor="ctr"/>
-          <a:lstStyle/>
-          <a:p>
-            <a:pPr algn="ctr">
-              <a:defRPr sz="1600" b="1">
-                <a:solidFill>
-                  <a:srgbClr val="FFFFFF"/>
-                </a:solidFill>
-              </a:defRPr>
-            </a:pPr>
-            <a:r>
-              <a:t>6</a:t>
-            </a:r>
-          </a:p>
-        </p:txBody>
-      </p:sp>
-      <p:sp>
-        <p:nvSpPr>
-          <p:cNvPr id="5" name="TextBox 4"/>
-          <p:cNvSpPr txBox="1"/>
-          <p:nvPr/>
-        </p:nvSpPr>
-        <p:spPr>
-          <a:xfrm>
-            <a:off x="731520" y="6446520"/>
-            <a:ext cx="10698480" cy="320040"/>
-          </a:xfrm>
-          <a:prstGeom prst="rect">
-            <a:avLst/>
-          </a:prstGeom>
-          <a:noFill/>
-        </p:spPr>
-        <p:txBody>
-          <a:bodyPr wrap="none">
-            <a:spAutoFit/>
-          </a:bodyPr>
-          <a:lstStyle/>
-          <a:p>
-            <a:pPr>
-              <a:defRPr sz="1000">
-                <a:solidFill>
-                  <a:srgbClr val="64748B"/>
-                </a:solidFill>
-                <a:latin typeface="Arial"/>
-              </a:defRPr>
-            </a:pPr>
-            <a:r>
-              <a:t>NER-LEWS  |  Disaster Risk Reduction Platform  |  Live App: https://ner-lews.vercel.app/</a:t>
-            </a:r>
-          </a:p>
-        </p:txBody>
-      </p:sp>
-      <p:sp>
-        <p:nvSpPr>
-          <p:cNvPr id="6" name="Rounded Rectangle 5"/>
-          <p:cNvSpPr/>
-          <p:nvPr/>
-        </p:nvSpPr>
-        <p:spPr>
-          <a:xfrm>
-            <a:off x="731520" y="1280160"/>
-            <a:ext cx="5486400" cy="4937760"/>
-          </a:xfrm>
-          <a:prstGeom prst="roundRect">
-            <a:avLst/>
-          </a:prstGeom>
-          <a:solidFill>
-            <a:srgbClr val="FFFFFF"/>
-          </a:solidFill>
-          <a:ln>
-            <a:solidFill>
-              <a:srgbClr val="CBD5E1"/>
-            </a:solidFill>
-          </a:ln>
-        </p:spPr>
-        <p:style>
-          <a:lnRef idx="1">
-            <a:schemeClr val="accent1"/>
-          </a:lnRef>
-          <a:fillRef idx="3">
-            <a:schemeClr val="accent1"/>
-          </a:fillRef>
-          <a:effectRef idx="2">
-            <a:schemeClr val="accent1"/>
-          </a:effectRef>
-          <a:fontRef idx="minor">
-            <a:schemeClr val="lt1"/>
-          </a:fontRef>
-        </p:style>
-        <p:txBody>
-          <a:bodyPr rtlCol="0" anchor="ctr" wrap="square" lIns="228600" tIns="228600"/>
-          <a:lstStyle/>
-          <a:p>
-            <a:pPr algn="ctr">
-              <a:defRPr sz="1300" b="1">
-                <a:solidFill>
-                  <a:srgbClr val="091426"/>
-                </a:solidFill>
-              </a:defRPr>
-            </a:pPr>
-            <a:r>
-              <a:t>📚 Scientific Grounding &amp; Live Links</a:t>
-            </a:r>
-          </a:p>
-          <a:p>
-            <a:pPr>
-              <a:defRPr sz="1000">
-                <a:solidFill>
-                  <a:srgbClr val="091426"/>
-                </a:solidFill>
-              </a:defRPr>
-            </a:pPr>
-            <a:r>
-              <a:t>• GSI Guidelines: National Landslide Susceptibility Mapping (NLSM) for Himalayan terrain.</a:t>
-            </a:r>
-          </a:p>
-          <a:p>
-            <a:pPr>
-              <a:defRPr sz="1000">
-                <a:solidFill>
-                  <a:srgbClr val="091426"/>
-                </a:solidFill>
-              </a:defRPr>
-            </a:pPr>
-            <a:r>
-              <a:t>• IMD Research: Rainfall intensity-duration thresholds for slope failure initiation in Meghalaya &amp; Mizoram.</a:t>
-            </a:r>
-          </a:p>
-          <a:p>
-            <a:pPr>
-              <a:defRPr sz="1000">
-                <a:solidFill>
-                  <a:srgbClr val="091426"/>
-                </a:solidFill>
-              </a:defRPr>
-            </a:pPr>
-            <a:r>
-              <a:t>• NESAC / ISRO: Early Warning Methodologies and rainfall zonation in East Khasi Hills.</a:t>
-            </a:r>
-          </a:p>
-          <a:p>
-            <a:pPr>
-              <a:defRPr sz="1000">
-                <a:solidFill>
-                  <a:srgbClr val="091426"/>
-                </a:solidFill>
-              </a:defRPr>
-            </a:pPr>
-            <a:r>
-              <a:t>• Web Application: https://ner-lews.vercel.app/ (Live on Vercel)</a:t>
-            </a:r>
-          </a:p>
-          <a:p>
-            <a:pPr>
-              <a:defRPr sz="1000">
-                <a:solidFill>
-                  <a:srgbClr val="091426"/>
-                </a:solidFill>
-              </a:defRPr>
-            </a:pPr>
-            <a:r>
-              <a:t>• REST API Server: https://ner-lews.onrender.com/ (Live on Render)</a:t>
-            </a:r>
-          </a:p>
-          <a:p>
-            <a:pPr>
-              <a:defRPr sz="1000">
-                <a:solidFill>
-                  <a:srgbClr val="091426"/>
-                </a:solidFill>
-              </a:defRPr>
-            </a:pPr>
-            <a:r>
-              <a:t>• Development: UI/UX structured with Stitch; full-stack engineered with Google Antigravity AI.</a:t>
-            </a:r>
-          </a:p>
-        </p:txBody>
-      </p:sp>
-      <p:pic>
-        <p:nvPicPr>
-          <p:cNvPr id="7" name="Picture 6" descr="06_authority_portal.png"/>
-          <p:cNvPicPr>
-            <a:picLocks noChangeAspect="1"/>
-          </p:cNvPicPr>
-          <p:nvPr/>
-        </p:nvPicPr>
-        <p:blipFill>
-          <a:blip r:embed="rId2"/>
-          <a:stretch>
-            <a:fillRect/>
-          </a:stretch>
-        </p:blipFill>
-        <p:spPr>
-          <a:xfrm>
-            <a:off x="6492240" y="1280160"/>
-            <a:ext cx="4937760" cy="2777490"/>
-          </a:xfrm>
-          <a:prstGeom prst="rect">
-            <a:avLst/>
-          </a:prstGeom>
-        </p:spPr>
-      </p:pic>
     </p:spTree>
   </p:cSld>
   <p:clrMapOvr>

</xml_diff>